<commit_message>
Repair 017 medical imaging visual review findings
</commit_message>
<xml_diff>
--- a/tests/fixtures/presentations/medical_imaging_group_meeting/visual_review_packet_source/medical_imaging_group_meeting_benchmark.pptx
+++ b/tests/fixtures/presentations/medical_imaging_group_meeting/visual_review_packet_source/medical_imaging_group_meeting_benchmark.pptx
@@ -3493,7 +3493,7 @@
             <a:avLst/>
           </a:prstGeom>
           <a:solidFill>
-            <a:srgbClr val="B0473F"/>
+            <a:srgbClr val="9A6A16"/>
           </a:solidFill>
           <a:ln>
             <a:noFill/>
@@ -3530,7 +3530,7 @@
         <p:spPr>
           <a:xfrm>
             <a:off x="1161288" y="5605272"/>
-            <a:ext cx="749808" cy="201168"/>
+            <a:ext cx="841248" cy="201168"/>
           </a:xfrm>
           <a:prstGeom prst="rect">
             <a:avLst/>
@@ -3565,7 +3565,7 @@
         </p:nvSpPr>
         <p:spPr>
           <a:xfrm>
-            <a:off x="1984248" y="5623560"/>
+            <a:off x="2103120" y="5623560"/>
             <a:ext cx="146304" cy="146304"/>
           </a:xfrm>
           <a:prstGeom prst="rect">
@@ -3608,8 +3608,8 @@
         </p:nvSpPr>
         <p:spPr>
           <a:xfrm>
-            <a:off x="2185416" y="5605272"/>
-            <a:ext cx="749808" cy="201168"/>
+            <a:off x="2304288" y="5605272"/>
+            <a:ext cx="841248" cy="201168"/>
           </a:xfrm>
           <a:prstGeom prst="rect">
             <a:avLst/>
@@ -3631,7 +3631,7 @@
               </a:defRPr>
             </a:pPr>
             <a:r>
-              <a:t>Prediction / TP</a:t>
+              <a:t>Pred / TP</a:t>
             </a:r>
           </a:p>
         </p:txBody>
@@ -3644,7 +3644,7 @@
         </p:nvSpPr>
         <p:spPr>
           <a:xfrm>
-            <a:off x="3008376" y="5623560"/>
+            <a:off x="3246120" y="5623560"/>
             <a:ext cx="146304" cy="146304"/>
           </a:xfrm>
           <a:prstGeom prst="rect">
@@ -3687,8 +3687,8 @@
         </p:nvSpPr>
         <p:spPr>
           <a:xfrm>
-            <a:off x="3209544" y="5605272"/>
-            <a:ext cx="749808" cy="201168"/>
+            <a:off x="3447288" y="5605272"/>
+            <a:ext cx="841248" cy="201168"/>
           </a:xfrm>
           <a:prstGeom prst="rect">
             <a:avLst/>
@@ -3723,7 +3723,7 @@
         </p:nvSpPr>
         <p:spPr>
           <a:xfrm>
-            <a:off x="4032504" y="5623560"/>
+            <a:off x="4389120" y="5623560"/>
             <a:ext cx="146304" cy="146304"/>
           </a:xfrm>
           <a:prstGeom prst="rect">
@@ -3766,8 +3766,8 @@
         </p:nvSpPr>
         <p:spPr>
           <a:xfrm>
-            <a:off x="4233672" y="5605272"/>
-            <a:ext cx="749808" cy="201168"/>
+            <a:off x="4590288" y="5605272"/>
+            <a:ext cx="841248" cy="201168"/>
           </a:xfrm>
           <a:prstGeom prst="rect">
             <a:avLst/>
@@ -3973,7 +3973,7 @@
       </p:sp>
       <p:pic>
         <p:nvPicPr>
-          <p:cNvPr id="6" name="Picture 5" descr="slide1_input.png"/>
+          <p:cNvPr id="6" name="Picture 5" descr="center_a_shift.png"/>
           <p:cNvPicPr>
             <a:picLocks noChangeAspect="1"/>
           </p:cNvPicPr>
@@ -3987,8 +3987,8 @@
         </p:blipFill>
         <p:spPr>
           <a:xfrm>
-            <a:off x="658368" y="1417320"/>
-            <a:ext cx="1600200" cy="1600200"/>
+            <a:off x="621792" y="1225296"/>
+            <a:ext cx="1078992" cy="1078992"/>
           </a:xfrm>
           <a:prstGeom prst="rect">
             <a:avLst/>
@@ -4003,8 +4003,8 @@
         </p:nvSpPr>
         <p:spPr>
           <a:xfrm>
-            <a:off x="594360" y="3182112"/>
-            <a:ext cx="1737360" cy="274320"/>
+            <a:off x="1792224" y="1408176"/>
+            <a:ext cx="932688" cy="219456"/>
           </a:xfrm>
           <a:prstGeom prst="rect">
             <a:avLst/>
@@ -4017,8 +4017,8 @@
           </a:bodyPr>
           <a:lstStyle/>
           <a:p>
-            <a:pPr algn="ctr">
-              <a:defRPr sz="1050" b="1">
+            <a:pPr algn="l">
+              <a:defRPr sz="1000" b="1">
                 <a:solidFill>
                   <a:srgbClr val="1C2430"/>
                 </a:solidFill>
@@ -4026,7 +4026,7 @@
               </a:defRPr>
             </a:pPr>
             <a:r>
-              <a:t>3 center conditions</a:t>
+              <a:t>Center A</a:t>
             </a:r>
           </a:p>
         </p:txBody>
@@ -4039,8 +4039,8 @@
         </p:nvSpPr>
         <p:spPr>
           <a:xfrm>
-            <a:off x="594360" y="3493008"/>
-            <a:ext cx="1737360" cy="256032"/>
+            <a:off x="1792224" y="1709928"/>
+            <a:ext cx="1024128" cy="292608"/>
           </a:xfrm>
           <a:prstGeom prst="rect">
             <a:avLst/>
@@ -4053,30 +4053,378 @@
           </a:bodyPr>
           <a:lstStyle/>
           <a:p>
+            <a:pPr algn="l">
+              <a:defRPr sz="869" b="0">
+                <a:solidFill>
+                  <a:srgbClr val="69717D"/>
+                </a:solidFill>
+                <a:latin typeface="Aptos"/>
+              </a:defRPr>
+            </a:pPr>
+            <a:r>
+              <a:t>reference contrast</a:t>
+            </a:r>
+          </a:p>
+        </p:txBody>
+      </p:sp>
+      <p:pic>
+        <p:nvPicPr>
+          <p:cNvPr id="9" name="Picture 8" descr="center_b_shift.png"/>
+          <p:cNvPicPr>
+            <a:picLocks noChangeAspect="1"/>
+          </p:cNvPicPr>
+          <p:nvPr/>
+        </p:nvPicPr>
+        <p:blipFill>
+          <a:blip r:embed="rId3"/>
+          <a:stretch>
+            <a:fillRect/>
+          </a:stretch>
+        </p:blipFill>
+        <p:spPr>
+          <a:xfrm>
+            <a:off x="621792" y="2523744"/>
+            <a:ext cx="1078992" cy="1078992"/>
+          </a:xfrm>
+          <a:prstGeom prst="rect">
+            <a:avLst/>
+          </a:prstGeom>
+        </p:spPr>
+      </p:pic>
+      <p:sp>
+        <p:nvSpPr>
+          <p:cNvPr id="10" name="TextBox 9"/>
+          <p:cNvSpPr txBox="1"/>
+          <p:nvPr/>
+        </p:nvSpPr>
+        <p:spPr>
+          <a:xfrm>
+            <a:off x="1792224" y="2706624"/>
+            <a:ext cx="932688" cy="219456"/>
+          </a:xfrm>
+          <a:prstGeom prst="rect">
+            <a:avLst/>
+          </a:prstGeom>
+          <a:noFill/>
+        </p:spPr>
+        <p:txBody>
+          <a:bodyPr wrap="square" lIns="36576" rIns="36576" tIns="18288" bIns="18288">
+            <a:spAutoFit/>
+          </a:bodyPr>
+          <a:lstStyle/>
+          <a:p>
+            <a:pPr algn="l">
+              <a:defRPr sz="1000" b="1">
+                <a:solidFill>
+                  <a:srgbClr val="1C2430"/>
+                </a:solidFill>
+                <a:latin typeface="Aptos"/>
+              </a:defRPr>
+            </a:pPr>
+            <a:r>
+              <a:t>Center B</a:t>
+            </a:r>
+          </a:p>
+        </p:txBody>
+      </p:sp>
+      <p:sp>
+        <p:nvSpPr>
+          <p:cNvPr id="11" name="TextBox 10"/>
+          <p:cNvSpPr txBox="1"/>
+          <p:nvPr/>
+        </p:nvSpPr>
+        <p:spPr>
+          <a:xfrm>
+            <a:off x="1792224" y="3008376"/>
+            <a:ext cx="1024128" cy="292608"/>
+          </a:xfrm>
+          <a:prstGeom prst="rect">
+            <a:avLst/>
+          </a:prstGeom>
+          <a:noFill/>
+        </p:spPr>
+        <p:txBody>
+          <a:bodyPr wrap="square" lIns="36576" rIns="36576" tIns="18288" bIns="18288">
+            <a:spAutoFit/>
+          </a:bodyPr>
+          <a:lstStyle/>
+          <a:p>
+            <a:pPr algn="l">
+              <a:defRPr sz="869" b="0">
+                <a:solidFill>
+                  <a:srgbClr val="69717D"/>
+                </a:solidFill>
+                <a:latin typeface="Aptos"/>
+              </a:defRPr>
+            </a:pPr>
+            <a:r>
+              <a:t>low contrast + bias</a:t>
+            </a:r>
+          </a:p>
+        </p:txBody>
+      </p:sp>
+      <p:pic>
+        <p:nvPicPr>
+          <p:cNvPr id="12" name="Picture 11" descr="center_c_shift.png"/>
+          <p:cNvPicPr>
+            <a:picLocks noChangeAspect="1"/>
+          </p:cNvPicPr>
+          <p:nvPr/>
+        </p:nvPicPr>
+        <p:blipFill>
+          <a:blip r:embed="rId4"/>
+          <a:stretch>
+            <a:fillRect/>
+          </a:stretch>
+        </p:blipFill>
+        <p:spPr>
+          <a:xfrm>
+            <a:off x="621792" y="3822191"/>
+            <a:ext cx="1078992" cy="1078992"/>
+          </a:xfrm>
+          <a:prstGeom prst="rect">
+            <a:avLst/>
+          </a:prstGeom>
+        </p:spPr>
+      </p:pic>
+      <p:sp>
+        <p:nvSpPr>
+          <p:cNvPr id="13" name="TextBox 12"/>
+          <p:cNvSpPr txBox="1"/>
+          <p:nvPr/>
+        </p:nvSpPr>
+        <p:spPr>
+          <a:xfrm>
+            <a:off x="1792224" y="4005072"/>
+            <a:ext cx="932688" cy="219456"/>
+          </a:xfrm>
+          <a:prstGeom prst="rect">
+            <a:avLst/>
+          </a:prstGeom>
+          <a:noFill/>
+        </p:spPr>
+        <p:txBody>
+          <a:bodyPr wrap="square" lIns="36576" rIns="36576" tIns="18288" bIns="18288">
+            <a:spAutoFit/>
+          </a:bodyPr>
+          <a:lstStyle/>
+          <a:p>
+            <a:pPr algn="l">
+              <a:defRPr sz="1000" b="1">
+                <a:solidFill>
+                  <a:srgbClr val="1C2430"/>
+                </a:solidFill>
+                <a:latin typeface="Aptos"/>
+              </a:defRPr>
+            </a:pPr>
+            <a:r>
+              <a:t>Center C</a:t>
+            </a:r>
+          </a:p>
+        </p:txBody>
+      </p:sp>
+      <p:sp>
+        <p:nvSpPr>
+          <p:cNvPr id="14" name="TextBox 13"/>
+          <p:cNvSpPr txBox="1"/>
+          <p:nvPr/>
+        </p:nvSpPr>
+        <p:spPr>
+          <a:xfrm>
+            <a:off x="1792224" y="4306824"/>
+            <a:ext cx="1024128" cy="292608"/>
+          </a:xfrm>
+          <a:prstGeom prst="rect">
+            <a:avLst/>
+          </a:prstGeom>
+          <a:noFill/>
+        </p:spPr>
+        <p:txBody>
+          <a:bodyPr wrap="square" lIns="36576" rIns="36576" tIns="18288" bIns="18288">
+            <a:spAutoFit/>
+          </a:bodyPr>
+          <a:lstStyle/>
+          <a:p>
+            <a:pPr algn="l">
+              <a:defRPr sz="869" b="0">
+                <a:solidFill>
+                  <a:srgbClr val="69717D"/>
+                </a:solidFill>
+                <a:latin typeface="Aptos"/>
+              </a:defRPr>
+            </a:pPr>
+            <a:r>
+              <a:t>high shift</a:t>
+            </a:r>
+          </a:p>
+        </p:txBody>
+      </p:sp>
+      <p:sp>
+        <p:nvSpPr>
+          <p:cNvPr id="15" name="TextBox 14"/>
+          <p:cNvSpPr txBox="1"/>
+          <p:nvPr/>
+        </p:nvSpPr>
+        <p:spPr>
+          <a:xfrm>
+            <a:off x="685800" y="5084064"/>
+            <a:ext cx="1883664" cy="256032"/>
+          </a:xfrm>
+          <a:prstGeom prst="rect">
+            <a:avLst/>
+          </a:prstGeom>
+          <a:noFill/>
+        </p:spPr>
+        <p:txBody>
+          <a:bodyPr wrap="square" lIns="36576" rIns="36576" tIns="18288" bIns="18288">
+            <a:spAutoFit/>
+          </a:bodyPr>
+          <a:lstStyle/>
+          <a:p>
             <a:pPr algn="ctr">
-              <a:defRPr sz="940" b="0">
-                <a:solidFill>
-                  <a:srgbClr val="69717D"/>
+              <a:defRPr sz="1019" b="1">
+                <a:solidFill>
+                  <a:srgbClr val="0F766E"/>
                 </a:solidFill>
                 <a:latin typeface="Aptos"/>
               </a:defRPr>
             </a:pPr>
             <a:r>
-              <a:t>contrast, noise, bias</a:t>
-            </a:r>
-          </a:p>
-        </p:txBody>
-      </p:sp>
-      <p:sp>
-        <p:nvSpPr>
-          <p:cNvPr id="9" name="Rounded Rectangle 8"/>
+              <a:t>appearance shift</a:t>
+            </a:r>
+          </a:p>
+        </p:txBody>
+      </p:sp>
+      <p:pic>
+        <p:nvPicPr>
+          <p:cNvPr id="16" name="Picture 15" descr="slide1_overlay.png"/>
+          <p:cNvPicPr>
+            <a:picLocks noChangeAspect="1"/>
+          </p:cNvPicPr>
+          <p:nvPr/>
+        </p:nvPicPr>
+        <p:blipFill>
+          <a:blip r:embed="rId5"/>
+          <a:stretch>
+            <a:fillRect/>
+          </a:stretch>
+        </p:blipFill>
+        <p:spPr>
+          <a:xfrm>
+            <a:off x="3072384" y="1828800"/>
+            <a:ext cx="1298448" cy="1298448"/>
+          </a:xfrm>
+          <a:prstGeom prst="rect">
+            <a:avLst/>
+          </a:prstGeom>
+        </p:spPr>
+      </p:pic>
+      <p:sp>
+        <p:nvSpPr>
+          <p:cNvPr id="17" name="TextBox 16"/>
+          <p:cNvSpPr txBox="1"/>
+          <p:nvPr/>
+        </p:nvSpPr>
+        <p:spPr>
+          <a:xfrm>
+            <a:off x="3072384" y="3236976"/>
+            <a:ext cx="1298448" cy="219456"/>
+          </a:xfrm>
+          <a:prstGeom prst="rect">
+            <a:avLst/>
+          </a:prstGeom>
+          <a:noFill/>
+        </p:spPr>
+        <p:txBody>
+          <a:bodyPr wrap="square" lIns="36576" rIns="36576" tIns="18288" bIns="18288">
+            <a:spAutoFit/>
+          </a:bodyPr>
+          <a:lstStyle/>
+          <a:p>
+            <a:pPr algn="ctr">
+              <a:defRPr sz="1050" b="1">
+                <a:solidFill>
+                  <a:srgbClr val="1C2430"/>
+                </a:solidFill>
+                <a:latin typeface="Aptos"/>
+              </a:defRPr>
+            </a:pPr>
+            <a:r>
+              <a:t>image + GT</a:t>
+            </a:r>
+          </a:p>
+        </p:txBody>
+      </p:sp>
+      <p:pic>
+        <p:nvPicPr>
+          <p:cNvPr id="18" name="Picture 17" descr="failure_pred.png"/>
+          <p:cNvPicPr>
+            <a:picLocks noChangeAspect="1"/>
+          </p:cNvPicPr>
+          <p:nvPr/>
+        </p:nvPicPr>
+        <p:blipFill>
+          <a:blip r:embed="rId6"/>
+          <a:stretch>
+            <a:fillRect/>
+          </a:stretch>
+        </p:blipFill>
+        <p:spPr>
+          <a:xfrm>
+            <a:off x="4956048" y="1828800"/>
+            <a:ext cx="1298448" cy="1298448"/>
+          </a:xfrm>
+          <a:prstGeom prst="rect">
+            <a:avLst/>
+          </a:prstGeom>
+        </p:spPr>
+      </p:pic>
+      <p:sp>
+        <p:nvSpPr>
+          <p:cNvPr id="19" name="TextBox 18"/>
+          <p:cNvSpPr txBox="1"/>
+          <p:nvPr/>
+        </p:nvSpPr>
+        <p:spPr>
+          <a:xfrm>
+            <a:off x="4956048" y="3236976"/>
+            <a:ext cx="1298448" cy="219456"/>
+          </a:xfrm>
+          <a:prstGeom prst="rect">
+            <a:avLst/>
+          </a:prstGeom>
+          <a:noFill/>
+        </p:spPr>
+        <p:txBody>
+          <a:bodyPr wrap="square" lIns="36576" rIns="36576" tIns="18288" bIns="18288">
+            <a:spAutoFit/>
+          </a:bodyPr>
+          <a:lstStyle/>
+          <a:p>
+            <a:pPr algn="ctr">
+              <a:defRPr sz="1050" b="1">
+                <a:solidFill>
+                  <a:srgbClr val="1C2430"/>
+                </a:solidFill>
+                <a:latin typeface="Aptos"/>
+              </a:defRPr>
+            </a:pPr>
+            <a:r>
+              <a:t>prediction</a:t>
+            </a:r>
+          </a:p>
+        </p:txBody>
+      </p:sp>
+      <p:sp>
+        <p:nvSpPr>
+          <p:cNvPr id="20" name="Rounded Rectangle 19"/>
           <p:cNvSpPr/>
           <p:nvPr/>
         </p:nvSpPr>
         <p:spPr>
           <a:xfrm>
-            <a:off x="2743200" y="1847088"/>
-            <a:ext cx="1627632" cy="960120"/>
+            <a:off x="6912864" y="1965960"/>
+            <a:ext cx="1517904" cy="822960"/>
           </a:xfrm>
           <a:prstGeom prst="roundRect">
             <a:avLst/>
@@ -4114,14 +4462,14 @@
       </p:sp>
       <p:sp>
         <p:nvSpPr>
-          <p:cNvPr id="10" name="TextBox 9"/>
+          <p:cNvPr id="21" name="TextBox 20"/>
           <p:cNvSpPr txBox="1"/>
           <p:nvPr/>
         </p:nvSpPr>
         <p:spPr>
           <a:xfrm>
-            <a:off x="2852928" y="1956816"/>
-            <a:ext cx="1408176" cy="777240"/>
+            <a:off x="7022592" y="2075688"/>
+            <a:ext cx="1298448" cy="640080"/>
           </a:xfrm>
           <a:prstGeom prst="rect">
             <a:avLst/>
@@ -4143,25 +4491,25 @@
               </a:defRPr>
             </a:pPr>
             <a:r>
-              <a:t>synthetic image</a:t>
+              <a:t>case metrics</a:t>
             </a:r>
             <a:br/>
             <a:r>
-              <a:t>+ GT lesion</a:t>
-            </a:r>
-          </a:p>
-        </p:txBody>
-      </p:sp>
-      <p:sp>
-        <p:nvSpPr>
-          <p:cNvPr id="11" name="Rounded Rectangle 10"/>
+              <a:t>Dice, recall, FP</a:t>
+            </a:r>
+          </a:p>
+        </p:txBody>
+      </p:sp>
+      <p:sp>
+        <p:nvSpPr>
+          <p:cNvPr id="22" name="Rounded Rectangle 21"/>
           <p:cNvSpPr/>
           <p:nvPr/>
         </p:nvSpPr>
         <p:spPr>
           <a:xfrm>
-            <a:off x="4882896" y="1847088"/>
-            <a:ext cx="1627632" cy="960120"/>
+            <a:off x="9089136" y="1965960"/>
+            <a:ext cx="1627632" cy="822960"/>
           </a:xfrm>
           <a:prstGeom prst="roundRect">
             <a:avLst/>
@@ -4199,14 +4547,14 @@
       </p:sp>
       <p:sp>
         <p:nvSpPr>
-          <p:cNvPr id="12" name="TextBox 11"/>
+          <p:cNvPr id="23" name="TextBox 22"/>
           <p:cNvSpPr txBox="1"/>
           <p:nvPr/>
         </p:nvSpPr>
         <p:spPr>
           <a:xfrm>
-            <a:off x="4992624" y="1956816"/>
-            <a:ext cx="1408176" cy="777240"/>
+            <a:off x="9198863" y="2075688"/>
+            <a:ext cx="1408176" cy="640080"/>
           </a:xfrm>
           <a:prstGeom prst="rect">
             <a:avLst/>
@@ -4228,176 +4576,6 @@
               </a:defRPr>
             </a:pPr>
             <a:r>
-              <a:t>deterministic</a:t>
-            </a:r>
-            <a:br/>
-            <a:r>
-              <a:t>prediction</a:t>
-            </a:r>
-          </a:p>
-        </p:txBody>
-      </p:sp>
-      <p:sp>
-        <p:nvSpPr>
-          <p:cNvPr id="13" name="Rounded Rectangle 12"/>
-          <p:cNvSpPr/>
-          <p:nvPr/>
-        </p:nvSpPr>
-        <p:spPr>
-          <a:xfrm>
-            <a:off x="7022592" y="1847088"/>
-            <a:ext cx="1627632" cy="960120"/>
-          </a:xfrm>
-          <a:prstGeom prst="roundRect">
-            <a:avLst/>
-          </a:prstGeom>
-          <a:solidFill>
-            <a:srgbClr val="FBFBF8"/>
-          </a:solidFill>
-          <a:ln w="12700">
-            <a:solidFill>
-              <a:srgbClr val="C7CDD3"/>
-            </a:solidFill>
-          </a:ln>
-        </p:spPr>
-        <p:style>
-          <a:lnRef idx="1">
-            <a:schemeClr val="accent1"/>
-          </a:lnRef>
-          <a:fillRef idx="3">
-            <a:schemeClr val="accent1"/>
-          </a:fillRef>
-          <a:effectRef idx="2">
-            <a:schemeClr val="accent1"/>
-          </a:effectRef>
-          <a:fontRef idx="minor">
-            <a:schemeClr val="lt1"/>
-          </a:fontRef>
-        </p:style>
-        <p:txBody>
-          <a:bodyPr rtlCol="0" anchor="ctr"/>
-          <a:lstStyle/>
-          <a:p>
-            <a:pPr algn="ctr"/>
-          </a:p>
-        </p:txBody>
-      </p:sp>
-      <p:sp>
-        <p:nvSpPr>
-          <p:cNvPr id="14" name="TextBox 13"/>
-          <p:cNvSpPr txBox="1"/>
-          <p:nvPr/>
-        </p:nvSpPr>
-        <p:spPr>
-          <a:xfrm>
-            <a:off x="7132320" y="1956816"/>
-            <a:ext cx="1408176" cy="777240"/>
-          </a:xfrm>
-          <a:prstGeom prst="rect">
-            <a:avLst/>
-          </a:prstGeom>
-          <a:noFill/>
-        </p:spPr>
-        <p:txBody>
-          <a:bodyPr wrap="square" lIns="36576" rIns="36576" tIns="18288" bIns="18288">
-            <a:spAutoFit/>
-          </a:bodyPr>
-          <a:lstStyle/>
-          <a:p>
-            <a:pPr algn="ctr">
-              <a:defRPr sz="1120" b="1">
-                <a:solidFill>
-                  <a:srgbClr val="1C2430"/>
-                </a:solidFill>
-                <a:latin typeface="Aptos"/>
-              </a:defRPr>
-            </a:pPr>
-            <a:r>
-              <a:t>case metrics</a:t>
-            </a:r>
-            <a:br/>
-            <a:r>
-              <a:t>Dice, recall, FP</a:t>
-            </a:r>
-          </a:p>
-        </p:txBody>
-      </p:sp>
-      <p:sp>
-        <p:nvSpPr>
-          <p:cNvPr id="15" name="Rounded Rectangle 14"/>
-          <p:cNvSpPr/>
-          <p:nvPr/>
-        </p:nvSpPr>
-        <p:spPr>
-          <a:xfrm>
-            <a:off x="9162288" y="1847088"/>
-            <a:ext cx="1627632" cy="960120"/>
-          </a:xfrm>
-          <a:prstGeom prst="roundRect">
-            <a:avLst/>
-          </a:prstGeom>
-          <a:solidFill>
-            <a:srgbClr val="FBFBF8"/>
-          </a:solidFill>
-          <a:ln w="12700">
-            <a:solidFill>
-              <a:srgbClr val="C7CDD3"/>
-            </a:solidFill>
-          </a:ln>
-        </p:spPr>
-        <p:style>
-          <a:lnRef idx="1">
-            <a:schemeClr val="accent1"/>
-          </a:lnRef>
-          <a:fillRef idx="3">
-            <a:schemeClr val="accent1"/>
-          </a:fillRef>
-          <a:effectRef idx="2">
-            <a:schemeClr val="accent1"/>
-          </a:effectRef>
-          <a:fontRef idx="minor">
-            <a:schemeClr val="lt1"/>
-          </a:fontRef>
-        </p:style>
-        <p:txBody>
-          <a:bodyPr rtlCol="0" anchor="ctr"/>
-          <a:lstStyle/>
-          <a:p>
-            <a:pPr algn="ctr"/>
-          </a:p>
-        </p:txBody>
-      </p:sp>
-      <p:sp>
-        <p:nvSpPr>
-          <p:cNvPr id="16" name="TextBox 15"/>
-          <p:cNvSpPr txBox="1"/>
-          <p:nvPr/>
-        </p:nvSpPr>
-        <p:spPr>
-          <a:xfrm>
-            <a:off x="9272015" y="1956816"/>
-            <a:ext cx="1408176" cy="777240"/>
-          </a:xfrm>
-          <a:prstGeom prst="rect">
-            <a:avLst/>
-          </a:prstGeom>
-          <a:noFill/>
-        </p:spPr>
-        <p:txBody>
-          <a:bodyPr wrap="square" lIns="36576" rIns="36576" tIns="18288" bIns="18288">
-            <a:spAutoFit/>
-          </a:bodyPr>
-          <a:lstStyle/>
-          <a:p>
-            <a:pPr algn="ctr">
-              <a:defRPr sz="1120" b="1">
-                <a:solidFill>
-                  <a:srgbClr val="1C2430"/>
-                </a:solidFill>
-                <a:latin typeface="Aptos"/>
-              </a:defRPr>
-            </a:pPr>
-            <a:r>
               <a:t>center summary</a:t>
             </a:r>
             <a:br/>
@@ -4409,14 +4587,14 @@
       </p:sp>
       <p:cxnSp>
         <p:nvCxnSpPr>
-          <p:cNvPr id="17" name="Connector 16"/>
+          <p:cNvPr id="24" name="Connector 23"/>
           <p:cNvCxnSpPr/>
           <p:nvPr/>
         </p:nvCxnSpPr>
         <p:spPr>
           <a:xfrm>
-            <a:off x="2267712" y="2331720"/>
-            <a:ext cx="475488" cy="0"/>
+            <a:off x="2670048" y="2331720"/>
+            <a:ext cx="402336" cy="0"/>
           </a:xfrm>
           <a:prstGeom prst="line">
             <a:avLst/>
@@ -4445,14 +4623,14 @@
       </p:cxnSp>
       <p:cxnSp>
         <p:nvCxnSpPr>
-          <p:cNvPr id="18" name="Connector 17"/>
+          <p:cNvPr id="25" name="Connector 24"/>
           <p:cNvCxnSpPr/>
           <p:nvPr/>
         </p:nvCxnSpPr>
         <p:spPr>
           <a:xfrm>
             <a:off x="4370832" y="2331720"/>
-            <a:ext cx="512064" cy="0"/>
+            <a:ext cx="585216" cy="0"/>
           </a:xfrm>
           <a:prstGeom prst="line">
             <a:avLst/>
@@ -4481,14 +4659,14 @@
       </p:cxnSp>
       <p:cxnSp>
         <p:nvCxnSpPr>
-          <p:cNvPr id="19" name="Connector 18"/>
+          <p:cNvPr id="26" name="Connector 25"/>
           <p:cNvCxnSpPr/>
           <p:nvPr/>
         </p:nvCxnSpPr>
         <p:spPr>
           <a:xfrm>
-            <a:off x="6510528" y="2331720"/>
-            <a:ext cx="512064" cy="0"/>
+            <a:off x="6254496" y="2331720"/>
+            <a:ext cx="658368" cy="0"/>
           </a:xfrm>
           <a:prstGeom prst="line">
             <a:avLst/>
@@ -4517,14 +4695,14 @@
       </p:cxnSp>
       <p:cxnSp>
         <p:nvCxnSpPr>
-          <p:cNvPr id="20" name="Connector 19"/>
+          <p:cNvPr id="27" name="Connector 26"/>
           <p:cNvCxnSpPr/>
           <p:nvPr/>
         </p:nvCxnSpPr>
         <p:spPr>
           <a:xfrm>
-            <a:off x="8650224" y="2331720"/>
-            <a:ext cx="512064" cy="0"/>
+            <a:off x="8430768" y="2331720"/>
+            <a:ext cx="658368" cy="0"/>
           </a:xfrm>
           <a:prstGeom prst="line">
             <a:avLst/>
@@ -4553,14 +4731,14 @@
       </p:cxnSp>
       <p:sp>
         <p:nvSpPr>
-          <p:cNvPr id="21" name="TextBox 20"/>
+          <p:cNvPr id="28" name="TextBox 27"/>
           <p:cNvSpPr txBox="1"/>
           <p:nvPr/>
         </p:nvSpPr>
         <p:spPr>
           <a:xfrm>
-            <a:off x="2761488" y="3246120"/>
-            <a:ext cx="7132320" cy="402336"/>
+            <a:off x="2980944" y="3840480"/>
+            <a:ext cx="7269480" cy="402336"/>
           </a:xfrm>
           <a:prstGeom prst="rect">
             <a:avLst/>
@@ -4574,7 +4752,7 @@
           <a:lstStyle/>
           <a:p>
             <a:pPr algn="l">
-              <a:defRPr sz="1320" b="1">
+              <a:defRPr sz="1300" b="1">
                 <a:solidFill>
                   <a:srgbClr val="0F766E"/>
                 </a:solidFill>
@@ -4582,21 +4760,21 @@
               </a:defRPr>
             </a:pPr>
             <a:r>
-              <a:t>Case-level metrics stay attached to the same image, GT and prediction before any center-level average.</a:t>
-            </a:r>
-          </a:p>
-        </p:txBody>
-      </p:sp>
-      <p:sp>
-        <p:nvSpPr>
-          <p:cNvPr id="22" name="TextBox 21"/>
+              <a:t>The same synthetic case carries image pixels, lesion mask, prediction and metrics before center-level averaging.</a:t>
+            </a:r>
+          </a:p>
+        </p:txBody>
+      </p:sp>
+      <p:sp>
+        <p:nvSpPr>
+          <p:cNvPr id="29" name="TextBox 28"/>
           <p:cNvSpPr txBox="1"/>
           <p:nvPr/>
         </p:nvSpPr>
         <p:spPr>
           <a:xfrm>
-            <a:off x="2761488" y="3840480"/>
-            <a:ext cx="7132320" cy="438912"/>
+            <a:off x="2980944" y="4434840"/>
+            <a:ext cx="7269480" cy="438912"/>
           </a:xfrm>
           <a:prstGeom prst="rect">
             <a:avLst/>
@@ -4625,14 +4803,14 @@
       </p:sp>
       <p:cxnSp>
         <p:nvCxnSpPr>
-          <p:cNvPr id="23" name="Connector 22"/>
+          <p:cNvPr id="30" name="Connector 29"/>
           <p:cNvCxnSpPr/>
           <p:nvPr/>
         </p:nvCxnSpPr>
         <p:spPr>
           <a:xfrm>
-            <a:off x="2697480" y="4526280"/>
-            <a:ext cx="7178040" cy="0"/>
+            <a:off x="2926080" y="5102352"/>
+            <a:ext cx="7315200" cy="0"/>
           </a:xfrm>
           <a:prstGeom prst="line">
             <a:avLst/>
@@ -4661,14 +4839,14 @@
       </p:cxnSp>
       <p:sp>
         <p:nvSpPr>
-          <p:cNvPr id="24" name="TextBox 23"/>
+          <p:cNvPr id="31" name="TextBox 30"/>
           <p:cNvSpPr txBox="1"/>
           <p:nvPr/>
         </p:nvSpPr>
         <p:spPr>
           <a:xfrm>
-            <a:off x="2926080" y="4736592"/>
-            <a:ext cx="6675120" cy="365760"/>
+            <a:off x="3154680" y="5321808"/>
+            <a:ext cx="6858000" cy="365760"/>
           </a:xfrm>
           <a:prstGeom prst="rect">
             <a:avLst/>
@@ -5400,7 +5578,7 @@
             <a:avLst/>
           </a:prstGeom>
           <a:solidFill>
-            <a:srgbClr val="B0473F"/>
+            <a:srgbClr val="9A6A16"/>
           </a:solidFill>
           <a:ln>
             <a:noFill/>
@@ -5437,7 +5615,7 @@
         <p:spPr>
           <a:xfrm>
             <a:off x="896112" y="4443984"/>
-            <a:ext cx="749808" cy="201168"/>
+            <a:ext cx="841248" cy="201168"/>
           </a:xfrm>
           <a:prstGeom prst="rect">
             <a:avLst/>
@@ -5472,7 +5650,7 @@
         </p:nvSpPr>
         <p:spPr>
           <a:xfrm>
-            <a:off x="1719072" y="4462272"/>
+            <a:off x="1837943" y="4462272"/>
             <a:ext cx="146304" cy="146304"/>
           </a:xfrm>
           <a:prstGeom prst="rect">
@@ -5515,8 +5693,8 @@
         </p:nvSpPr>
         <p:spPr>
           <a:xfrm>
-            <a:off x="1920240" y="4443984"/>
-            <a:ext cx="749808" cy="201168"/>
+            <a:off x="2039112" y="4443984"/>
+            <a:ext cx="841248" cy="201168"/>
           </a:xfrm>
           <a:prstGeom prst="rect">
             <a:avLst/>
@@ -5538,7 +5716,7 @@
               </a:defRPr>
             </a:pPr>
             <a:r>
-              <a:t>Prediction / TP</a:t>
+              <a:t>Pred / TP</a:t>
             </a:r>
           </a:p>
         </p:txBody>
@@ -5551,7 +5729,7 @@
         </p:nvSpPr>
         <p:spPr>
           <a:xfrm>
-            <a:off x="2743200" y="4462272"/>
+            <a:off x="2980944" y="4462272"/>
             <a:ext cx="146304" cy="146304"/>
           </a:xfrm>
           <a:prstGeom prst="rect">
@@ -5594,8 +5772,8 @@
         </p:nvSpPr>
         <p:spPr>
           <a:xfrm>
-            <a:off x="2944368" y="4443984"/>
-            <a:ext cx="749808" cy="201168"/>
+            <a:off x="3182112" y="4443984"/>
+            <a:ext cx="841248" cy="201168"/>
           </a:xfrm>
           <a:prstGeom prst="rect">
             <a:avLst/>
@@ -5630,7 +5808,7 @@
         </p:nvSpPr>
         <p:spPr>
           <a:xfrm>
-            <a:off x="3767328" y="4462272"/>
+            <a:off x="4123944" y="4462272"/>
             <a:ext cx="146304" cy="146304"/>
           </a:xfrm>
           <a:prstGeom prst="rect">
@@ -5673,8 +5851,8 @@
         </p:nvSpPr>
         <p:spPr>
           <a:xfrm>
-            <a:off x="3968496" y="4443984"/>
-            <a:ext cx="749808" cy="201168"/>
+            <a:off x="4325112" y="4443984"/>
+            <a:ext cx="841248" cy="201168"/>
           </a:xfrm>
           <a:prstGeom prst="rect">
             <a:avLst/>

</xml_diff>

<commit_message>
Label 017 medical imaging anatomy target
</commit_message>
<xml_diff>
--- a/tests/fixtures/presentations/medical_imaging_group_meeting/visual_review_packet_source/medical_imaging_group_meeting_benchmark.pptx
+++ b/tests/fixtures/presentations/medical_imaging_group_meeting/visual_review_packet_source/medical_imaging_group_meeting_benchmark.pptx
@@ -3301,14 +3301,57 @@
       </p:pic>
       <p:sp>
         <p:nvSpPr>
-          <p:cNvPr id="8" name="TextBox 7"/>
+          <p:cNvPr id="8" name="Rounded Rectangle 7"/>
+          <p:cNvSpPr/>
+          <p:nvPr/>
+        </p:nvSpPr>
+        <p:spPr>
+          <a:xfrm>
+            <a:off x="1051560" y="4005072"/>
+            <a:ext cx="987552" cy="237744"/>
+          </a:xfrm>
+          <a:prstGeom prst="roundRect">
+            <a:avLst/>
+          </a:prstGeom>
+          <a:solidFill>
+            <a:srgbClr val="243B53"/>
+          </a:solidFill>
+          <a:ln>
+            <a:noFill/>
+          </a:ln>
+        </p:spPr>
+        <p:style>
+          <a:lnRef idx="1">
+            <a:schemeClr val="accent1"/>
+          </a:lnRef>
+          <a:fillRef idx="3">
+            <a:schemeClr val="accent1"/>
+          </a:fillRef>
+          <a:effectRef idx="2">
+            <a:schemeClr val="accent1"/>
+          </a:effectRef>
+          <a:fontRef idx="minor">
+            <a:schemeClr val="lt1"/>
+          </a:fontRef>
+        </p:style>
+        <p:txBody>
+          <a:bodyPr rtlCol="0" anchor="ctr"/>
+          <a:lstStyle/>
+          <a:p>
+            <a:pPr algn="ctr"/>
+          </a:p>
+        </p:txBody>
+      </p:sp>
+      <p:sp>
+        <p:nvSpPr>
+          <p:cNvPr id="9" name="TextBox 8"/>
           <p:cNvSpPr txBox="1"/>
           <p:nvPr/>
         </p:nvSpPr>
         <p:spPr>
           <a:xfrm>
-            <a:off x="8732520" y="1371600"/>
-            <a:ext cx="2606040" cy="713232"/>
+            <a:off x="1106424" y="4032504"/>
+            <a:ext cx="877824" cy="164592"/>
           </a:xfrm>
           <a:prstGeom prst="rect">
             <a:avLst/>
@@ -3321,145 +3364,37 @@
           </a:bodyPr>
           <a:lstStyle/>
           <a:p>
-            <a:pPr algn="l">
-              <a:defRPr sz="1500" b="1">
-                <a:solidFill>
-                  <a:srgbClr val="1C2430"/>
+            <a:pPr algn="ctr">
+              <a:defRPr sz="800" b="1">
+                <a:solidFill>
+                  <a:srgbClr val="FFFFFF"/>
                 </a:solidFill>
                 <a:latin typeface="Aptos"/>
               </a:defRPr>
             </a:pPr>
             <a:r>
-              <a:t>Evaluation unit: lesion detection + mask overlap</a:t>
-            </a:r>
-          </a:p>
-        </p:txBody>
-      </p:sp>
-      <p:sp>
-        <p:nvSpPr>
-          <p:cNvPr id="9" name="TextBox 8"/>
-          <p:cNvSpPr txBox="1"/>
-          <p:nvPr/>
-        </p:nvSpPr>
-        <p:spPr>
-          <a:xfrm>
-            <a:off x="8732520" y="2231136"/>
-            <a:ext cx="2514600" cy="694944"/>
-          </a:xfrm>
-          <a:prstGeom prst="rect">
-            <a:avLst/>
-          </a:prstGeom>
-          <a:noFill/>
-        </p:spPr>
-        <p:txBody>
-          <a:bodyPr wrap="square" lIns="36576" rIns="36576" tIns="18288" bIns="18288">
-            <a:spAutoFit/>
-          </a:bodyPr>
-          <a:lstStyle/>
-          <a:p>
-            <a:pPr algn="l">
-              <a:defRPr sz="1220" b="0">
-                <a:solidFill>
-                  <a:srgbClr val="69717D"/>
-                </a:solidFill>
-                <a:latin typeface="Aptos"/>
-              </a:defRPr>
-            </a:pPr>
-            <a:r>
-              <a:t>Dice summarizes mask overlap, but a missed small lesion is counted at the lesion level.</a:t>
-            </a:r>
-          </a:p>
-        </p:txBody>
-      </p:sp>
-      <p:sp>
-        <p:nvSpPr>
-          <p:cNvPr id="10" name="TextBox 9"/>
-          <p:cNvSpPr txBox="1"/>
-          <p:nvPr/>
-        </p:nvSpPr>
-        <p:spPr>
-          <a:xfrm>
-            <a:off x="8732520" y="3218688"/>
-            <a:ext cx="2514600" cy="530352"/>
-          </a:xfrm>
-          <a:prstGeom prst="rect">
-            <a:avLst/>
-          </a:prstGeom>
-          <a:noFill/>
-        </p:spPr>
-        <p:txBody>
-          <a:bodyPr wrap="square" lIns="36576" rIns="36576" tIns="18288" bIns="18288">
-            <a:spAutoFit/>
-          </a:bodyPr>
-          <a:lstStyle/>
-          <a:p>
-            <a:pPr algn="l">
-              <a:defRPr sz="1220" b="1">
-                <a:solidFill>
-                  <a:srgbClr val="0F766E"/>
-                </a:solidFill>
-                <a:latin typeface="Aptos"/>
-              </a:defRPr>
-            </a:pPr>
-            <a:r>
-              <a:t>Endpoints: Dice overlap, lesion recall, false-positive burden</a:t>
-            </a:r>
-          </a:p>
-        </p:txBody>
-      </p:sp>
-      <p:sp>
-        <p:nvSpPr>
-          <p:cNvPr id="11" name="TextBox 10"/>
-          <p:cNvSpPr txBox="1"/>
-          <p:nvPr/>
-        </p:nvSpPr>
-        <p:spPr>
-          <a:xfrm>
-            <a:off x="8732520" y="4224528"/>
-            <a:ext cx="2514600" cy="530352"/>
-          </a:xfrm>
-          <a:prstGeom prst="rect">
-            <a:avLst/>
-          </a:prstGeom>
-          <a:noFill/>
-        </p:spPr>
-        <p:txBody>
-          <a:bodyPr wrap="square" lIns="36576" rIns="36576" tIns="18288" bIns="18288">
-            <a:spAutoFit/>
-          </a:bodyPr>
-          <a:lstStyle/>
-          <a:p>
-            <a:pPr algn="l">
-              <a:defRPr sz="1140" b="0">
-                <a:solidFill>
-                  <a:srgbClr val="69717D"/>
-                </a:solidFill>
-                <a:latin typeface="Aptos"/>
-              </a:defRPr>
-            </a:pPr>
-            <a:r>
-              <a:t>Synthetic cardiac-MR-like phantoms; not clinical validation.</a:t>
+              <a:t>myocardial ring</a:t>
             </a:r>
           </a:p>
         </p:txBody>
       </p:sp>
       <p:cxnSp>
         <p:nvCxnSpPr>
-          <p:cNvPr id="12" name="Connector 11"/>
+          <p:cNvPr id="10" name="Connector 9"/>
           <p:cNvCxnSpPr/>
           <p:nvPr/>
         </p:nvCxnSpPr>
         <p:spPr>
-          <a:xfrm>
-            <a:off x="640080" y="5440680"/>
-            <a:ext cx="7726680" cy="0"/>
+          <a:xfrm flipV="1">
+            <a:off x="1901952" y="3273552"/>
+            <a:ext cx="402336" cy="694944"/>
           </a:xfrm>
           <a:prstGeom prst="line">
             <a:avLst/>
           </a:prstGeom>
-          <a:ln w="13970">
+          <a:ln w="17780">
             <a:solidFill>
-              <a:srgbClr val="C7CDD3"/>
+              <a:srgbClr val="9A6A16"/>
             </a:solidFill>
           </a:ln>
         </p:spPr>
@@ -3480,7 +3415,300 @@
       </p:cxnSp>
       <p:sp>
         <p:nvSpPr>
-          <p:cNvPr id="13" name="Rectangle 12"/>
+          <p:cNvPr id="11" name="Rounded Rectangle 10"/>
+          <p:cNvSpPr/>
+          <p:nvPr/>
+        </p:nvSpPr>
+        <p:spPr>
+          <a:xfrm>
+            <a:off x="3072384" y="2542032"/>
+            <a:ext cx="1188720" cy="237744"/>
+          </a:xfrm>
+          <a:prstGeom prst="roundRect">
+            <a:avLst/>
+          </a:prstGeom>
+          <a:solidFill>
+            <a:srgbClr val="243B53"/>
+          </a:solidFill>
+          <a:ln>
+            <a:noFill/>
+          </a:ln>
+        </p:spPr>
+        <p:style>
+          <a:lnRef idx="1">
+            <a:schemeClr val="accent1"/>
+          </a:lnRef>
+          <a:fillRef idx="3">
+            <a:schemeClr val="accent1"/>
+          </a:fillRef>
+          <a:effectRef idx="2">
+            <a:schemeClr val="accent1"/>
+          </a:effectRef>
+          <a:fontRef idx="minor">
+            <a:schemeClr val="lt1"/>
+          </a:fontRef>
+        </p:style>
+        <p:txBody>
+          <a:bodyPr rtlCol="0" anchor="ctr"/>
+          <a:lstStyle/>
+          <a:p>
+            <a:pPr algn="ctr"/>
+          </a:p>
+        </p:txBody>
+      </p:sp>
+      <p:sp>
+        <p:nvSpPr>
+          <p:cNvPr id="12" name="TextBox 11"/>
+          <p:cNvSpPr txBox="1"/>
+          <p:nvPr/>
+        </p:nvSpPr>
+        <p:spPr>
+          <a:xfrm>
+            <a:off x="3127248" y="2569463"/>
+            <a:ext cx="1078992" cy="164592"/>
+          </a:xfrm>
+          <a:prstGeom prst="rect">
+            <a:avLst/>
+          </a:prstGeom>
+          <a:noFill/>
+        </p:spPr>
+        <p:txBody>
+          <a:bodyPr wrap="square" lIns="36576" rIns="36576" tIns="18288" bIns="18288">
+            <a:spAutoFit/>
+          </a:bodyPr>
+          <a:lstStyle/>
+          <a:p>
+            <a:pPr algn="ctr">
+              <a:defRPr sz="800" b="1">
+                <a:solidFill>
+                  <a:srgbClr val="FFFFFF"/>
+                </a:solidFill>
+                <a:latin typeface="Aptos"/>
+              </a:defRPr>
+            </a:pPr>
+            <a:r>
+              <a:t>small lesion target</a:t>
+            </a:r>
+          </a:p>
+        </p:txBody>
+      </p:sp>
+      <p:cxnSp>
+        <p:nvCxnSpPr>
+          <p:cNvPr id="13" name="Connector 12"/>
+          <p:cNvCxnSpPr/>
+          <p:nvPr/>
+        </p:nvCxnSpPr>
+        <p:spPr>
+          <a:xfrm flipH="1">
+            <a:off x="3328416" y="2779776"/>
+            <a:ext cx="219456" cy="201168"/>
+          </a:xfrm>
+          <a:prstGeom prst="line">
+            <a:avLst/>
+          </a:prstGeom>
+          <a:ln w="17780">
+            <a:solidFill>
+              <a:srgbClr val="9A6A16"/>
+            </a:solidFill>
+          </a:ln>
+        </p:spPr>
+        <p:style>
+          <a:lnRef idx="2">
+            <a:schemeClr val="accent1"/>
+          </a:lnRef>
+          <a:fillRef idx="0">
+            <a:schemeClr val="accent1"/>
+          </a:fillRef>
+          <a:effectRef idx="1">
+            <a:schemeClr val="accent1"/>
+          </a:effectRef>
+          <a:fontRef idx="minor">
+            <a:schemeClr val="tx1"/>
+          </a:fontRef>
+        </p:style>
+      </p:cxnSp>
+      <p:sp>
+        <p:nvSpPr>
+          <p:cNvPr id="14" name="TextBox 13"/>
+          <p:cNvSpPr txBox="1"/>
+          <p:nvPr/>
+        </p:nvSpPr>
+        <p:spPr>
+          <a:xfrm>
+            <a:off x="8732520" y="1371600"/>
+            <a:ext cx="2606040" cy="713232"/>
+          </a:xfrm>
+          <a:prstGeom prst="rect">
+            <a:avLst/>
+          </a:prstGeom>
+          <a:noFill/>
+        </p:spPr>
+        <p:txBody>
+          <a:bodyPr wrap="square" lIns="36576" rIns="36576" tIns="18288" bIns="18288">
+            <a:spAutoFit/>
+          </a:bodyPr>
+          <a:lstStyle/>
+          <a:p>
+            <a:pPr algn="l">
+              <a:defRPr sz="1500" b="1">
+                <a:solidFill>
+                  <a:srgbClr val="1C2430"/>
+                </a:solidFill>
+                <a:latin typeface="Aptos"/>
+              </a:defRPr>
+            </a:pPr>
+            <a:r>
+              <a:t>Evaluation unit: lesion detection + mask overlap</a:t>
+            </a:r>
+          </a:p>
+        </p:txBody>
+      </p:sp>
+      <p:sp>
+        <p:nvSpPr>
+          <p:cNvPr id="15" name="TextBox 14"/>
+          <p:cNvSpPr txBox="1"/>
+          <p:nvPr/>
+        </p:nvSpPr>
+        <p:spPr>
+          <a:xfrm>
+            <a:off x="8732520" y="2231136"/>
+            <a:ext cx="2514600" cy="694944"/>
+          </a:xfrm>
+          <a:prstGeom prst="rect">
+            <a:avLst/>
+          </a:prstGeom>
+          <a:noFill/>
+        </p:spPr>
+        <p:txBody>
+          <a:bodyPr wrap="square" lIns="36576" rIns="36576" tIns="18288" bIns="18288">
+            <a:spAutoFit/>
+          </a:bodyPr>
+          <a:lstStyle/>
+          <a:p>
+            <a:pPr algn="l">
+              <a:defRPr sz="1220" b="0">
+                <a:solidFill>
+                  <a:srgbClr val="69717D"/>
+                </a:solidFill>
+                <a:latin typeface="Aptos"/>
+              </a:defRPr>
+            </a:pPr>
+            <a:r>
+              <a:t>Dice summarizes mask overlap, but a missed small lesion is counted at the lesion level.</a:t>
+            </a:r>
+          </a:p>
+        </p:txBody>
+      </p:sp>
+      <p:sp>
+        <p:nvSpPr>
+          <p:cNvPr id="16" name="TextBox 15"/>
+          <p:cNvSpPr txBox="1"/>
+          <p:nvPr/>
+        </p:nvSpPr>
+        <p:spPr>
+          <a:xfrm>
+            <a:off x="8732520" y="3218688"/>
+            <a:ext cx="2514600" cy="530352"/>
+          </a:xfrm>
+          <a:prstGeom prst="rect">
+            <a:avLst/>
+          </a:prstGeom>
+          <a:noFill/>
+        </p:spPr>
+        <p:txBody>
+          <a:bodyPr wrap="square" lIns="36576" rIns="36576" tIns="18288" bIns="18288">
+            <a:spAutoFit/>
+          </a:bodyPr>
+          <a:lstStyle/>
+          <a:p>
+            <a:pPr algn="l">
+              <a:defRPr sz="1220" b="1">
+                <a:solidFill>
+                  <a:srgbClr val="0F766E"/>
+                </a:solidFill>
+                <a:latin typeface="Aptos"/>
+              </a:defRPr>
+            </a:pPr>
+            <a:r>
+              <a:t>Endpoints: Dice overlap, lesion recall, false-positive burden</a:t>
+            </a:r>
+          </a:p>
+        </p:txBody>
+      </p:sp>
+      <p:sp>
+        <p:nvSpPr>
+          <p:cNvPr id="17" name="TextBox 16"/>
+          <p:cNvSpPr txBox="1"/>
+          <p:nvPr/>
+        </p:nvSpPr>
+        <p:spPr>
+          <a:xfrm>
+            <a:off x="8732520" y="4224528"/>
+            <a:ext cx="2514600" cy="530352"/>
+          </a:xfrm>
+          <a:prstGeom prst="rect">
+            <a:avLst/>
+          </a:prstGeom>
+          <a:noFill/>
+        </p:spPr>
+        <p:txBody>
+          <a:bodyPr wrap="square" lIns="36576" rIns="36576" tIns="18288" bIns="18288">
+            <a:spAutoFit/>
+          </a:bodyPr>
+          <a:lstStyle/>
+          <a:p>
+            <a:pPr algn="l">
+              <a:defRPr sz="1140" b="0">
+                <a:solidFill>
+                  <a:srgbClr val="69717D"/>
+                </a:solidFill>
+                <a:latin typeface="Aptos"/>
+              </a:defRPr>
+            </a:pPr>
+            <a:r>
+              <a:t>Synthetic cardiac-MR-like phantoms; not clinical validation.</a:t>
+            </a:r>
+          </a:p>
+        </p:txBody>
+      </p:sp>
+      <p:cxnSp>
+        <p:nvCxnSpPr>
+          <p:cNvPr id="18" name="Connector 17"/>
+          <p:cNvCxnSpPr/>
+          <p:nvPr/>
+        </p:nvCxnSpPr>
+        <p:spPr>
+          <a:xfrm>
+            <a:off x="640080" y="5440680"/>
+            <a:ext cx="7726680" cy="0"/>
+          </a:xfrm>
+          <a:prstGeom prst="line">
+            <a:avLst/>
+          </a:prstGeom>
+          <a:ln w="13970">
+            <a:solidFill>
+              <a:srgbClr val="C7CDD3"/>
+            </a:solidFill>
+          </a:ln>
+        </p:spPr>
+        <p:style>
+          <a:lnRef idx="2">
+            <a:schemeClr val="accent1"/>
+          </a:lnRef>
+          <a:fillRef idx="0">
+            <a:schemeClr val="accent1"/>
+          </a:fillRef>
+          <a:effectRef idx="1">
+            <a:schemeClr val="accent1"/>
+          </a:effectRef>
+          <a:fontRef idx="minor">
+            <a:schemeClr val="tx1"/>
+          </a:fontRef>
+        </p:style>
+      </p:cxnSp>
+      <p:sp>
+        <p:nvSpPr>
+          <p:cNvPr id="19" name="Rectangle 18"/>
           <p:cNvSpPr/>
           <p:nvPr/>
         </p:nvSpPr>
@@ -3523,7 +3751,7 @@
       </p:sp>
       <p:sp>
         <p:nvSpPr>
-          <p:cNvPr id="14" name="TextBox 13"/>
+          <p:cNvPr id="20" name="TextBox 19"/>
           <p:cNvSpPr txBox="1"/>
           <p:nvPr/>
         </p:nvSpPr>
@@ -3559,7 +3787,7 @@
       </p:sp>
       <p:sp>
         <p:nvSpPr>
-          <p:cNvPr id="15" name="Rectangle 14"/>
+          <p:cNvPr id="21" name="Rectangle 20"/>
           <p:cNvSpPr/>
           <p:nvPr/>
         </p:nvSpPr>
@@ -3602,7 +3830,7 @@
       </p:sp>
       <p:sp>
         <p:nvSpPr>
-          <p:cNvPr id="16" name="TextBox 15"/>
+          <p:cNvPr id="22" name="TextBox 21"/>
           <p:cNvSpPr txBox="1"/>
           <p:nvPr/>
         </p:nvSpPr>
@@ -3638,7 +3866,7 @@
       </p:sp>
       <p:sp>
         <p:nvSpPr>
-          <p:cNvPr id="17" name="Rectangle 16"/>
+          <p:cNvPr id="23" name="Rectangle 22"/>
           <p:cNvSpPr/>
           <p:nvPr/>
         </p:nvSpPr>
@@ -3681,7 +3909,7 @@
       </p:sp>
       <p:sp>
         <p:nvSpPr>
-          <p:cNvPr id="18" name="TextBox 17"/>
+          <p:cNvPr id="24" name="TextBox 23"/>
           <p:cNvSpPr txBox="1"/>
           <p:nvPr/>
         </p:nvSpPr>
@@ -3717,7 +3945,7 @@
       </p:sp>
       <p:sp>
         <p:nvSpPr>
-          <p:cNvPr id="19" name="Rectangle 18"/>
+          <p:cNvPr id="25" name="Rectangle 24"/>
           <p:cNvSpPr/>
           <p:nvPr/>
         </p:nvSpPr>
@@ -3760,7 +3988,7 @@
       </p:sp>
       <p:sp>
         <p:nvSpPr>
-          <p:cNvPr id="20" name="TextBox 19"/>
+          <p:cNvPr id="26" name="TextBox 25"/>
           <p:cNvSpPr txBox="1"/>
           <p:nvPr/>
         </p:nvSpPr>

</xml_diff>